<commit_message>
Add multi-agent design doc, README rewrite, presentation
</commit_message>
<xml_diff>
--- a/docs/loupe-presentation.pptx
+++ b/docs/loupe-presentation.pptx
@@ -3723,31 +3723,6 @@
       </p:grpSpPr>
       <p:sp>
         <p:nvSpPr>
-          <p:cNvPr id="2" name="Shape 0"/>
-          <p:cNvSpPr/>
-          <p:nvPr/>
-        </p:nvSpPr>
-        <p:spPr>
-          <a:xfrm>
-            <a:off x="9509760" y="4023360"/>
-            <a:ext cx="2011680" cy="2011680"/>
-          </a:xfrm>
-          <a:prstGeom prst="ellipse">
-            <a:avLst/>
-          </a:prstGeom>
-          <a:solidFill>
-            <a:srgbClr val="1E2761"/>
-          </a:solidFill>
-          <a:ln w="19050">
-            <a:solidFill>
-              <a:srgbClr val="CADCFC"/>
-            </a:solidFill>
-            <a:prstDash val="solid"/>
-          </a:ln>
-        </p:spPr>
-      </p:sp>
-      <p:sp>
-        <p:nvSpPr>
           <p:cNvPr id="3" name="Text 1"/>
           <p:cNvSpPr/>
           <p:nvPr/>
@@ -4111,6 +4086,110 @@
           </a:p>
         </p:txBody>
       </p:sp>
+      <p:grpSp>
+        <p:nvGrpSpPr>
+          <p:cNvPr id="13" name="Group 12"/>
+          <p:cNvGrpSpPr/>
+          <p:nvPr/>
+        </p:nvGrpSpPr>
+        <p:grpSpPr>
+          <a:xfrm>
+            <a:off x="9609908" y="4345725"/>
+            <a:ext cx="1639127" cy="1597875"/>
+            <a:chOff x="7741344" y="4551578"/>
+            <a:chExt cx="1928436" cy="1894942"/>
+          </a:xfrm>
+        </p:grpSpPr>
+        <p:sp>
+          <p:nvSpPr>
+            <p:cNvPr id="10" name="Shape 0"/>
+            <p:cNvSpPr/>
+            <p:nvPr/>
+          </p:nvSpPr>
+          <p:spPr>
+            <a:xfrm>
+              <a:off x="7741344" y="4551578"/>
+              <a:ext cx="1928436" cy="1894942"/>
+            </a:xfrm>
+            <a:prstGeom prst="ellipse">
+              <a:avLst/>
+            </a:prstGeom>
+            <a:solidFill>
+              <a:srgbClr val="1E2761"/>
+            </a:solidFill>
+            <a:ln w="25400">
+              <a:solidFill>
+                <a:srgbClr val="CADCFC"/>
+              </a:solidFill>
+              <a:prstDash val="solid"/>
+            </a:ln>
+          </p:spPr>
+        </p:sp>
+        <p:sp>
+          <p:nvSpPr>
+            <p:cNvPr id="11" name="Shape 1"/>
+            <p:cNvSpPr/>
+            <p:nvPr/>
+          </p:nvSpPr>
+          <p:spPr>
+            <a:xfrm>
+              <a:off x="8030653" y="4848645"/>
+              <a:ext cx="1349818" cy="1300808"/>
+            </a:xfrm>
+            <a:prstGeom prst="ellipse">
+              <a:avLst/>
+            </a:prstGeom>
+            <a:solidFill>
+              <a:srgbClr val="141A45"/>
+            </a:solidFill>
+            <a:ln w="19050">
+              <a:solidFill>
+                <a:srgbClr val="E8A33D"/>
+              </a:solidFill>
+              <a:prstDash val="solid"/>
+            </a:ln>
+          </p:spPr>
+        </p:sp>
+        <p:sp>
+          <p:nvSpPr>
+            <p:cNvPr id="12" name="Text 2"/>
+            <p:cNvSpPr/>
+            <p:nvPr/>
+          </p:nvSpPr>
+          <p:spPr>
+            <a:xfrm>
+              <a:off x="8344907" y="5207484"/>
+              <a:ext cx="721310" cy="583130"/>
+            </a:xfrm>
+            <a:prstGeom prst="rect">
+              <a:avLst/>
+            </a:prstGeom>
+            <a:noFill/>
+            <a:ln/>
+          </p:spPr>
+          <p:txBody>
+            <a:bodyPr wrap="square" lIns="0" tIns="0" rIns="0" bIns="0" rtlCol="0" anchor="ctr"/>
+            <a:lstStyle/>
+            <a:p>
+              <a:pPr marL="0" indent="0" algn="ctr">
+                <a:buNone/>
+              </a:pPr>
+              <a:r>
+                <a:rPr lang="en-US" sz="2800" b="1" dirty="0" smtClean="0">
+                  <a:solidFill>
+                    <a:srgbClr val="E8A33D"/>
+                  </a:solidFill>
+                  <a:latin typeface="Cambria" pitchFamily="34" charset="0"/>
+                  <a:ea typeface="Cambria" pitchFamily="34" charset="-122"/>
+                  <a:cs typeface="Cambria" pitchFamily="34" charset="-120"/>
+                </a:rPr>
+                <a:t>3/3</a:t>
+              </a:r>
+              <a:endParaRPr lang="en-US" sz="2800" dirty="0"/>
+            </a:p>
+          </p:txBody>
+        </p:sp>
+      </p:grpSp>
     </p:spTree>
   </p:cSld>
   <p:clrMapOvr>

</xml_diff>